<commit_message>
chore: add sample tracking frames and project presentation slides
</commit_message>
<xml_diff>
--- a/Docs/G07_M3_Presentation_v2.pptx
+++ b/Docs/G07_M3_Presentation_v2.pptx
@@ -4881,6 +4881,54 @@
           <a:p>
             <a:pPr algn="ctr"/>
             <a:endParaRPr dirty="0"/>
+          </a:p>
+        </p:txBody>
+      </p:sp>
+      <p:sp>
+        <p:nvSpPr>
+          <p:cNvPr id="11" name="TextBox 10">
+            <a:extLst>
+              <a:ext uri="{FF2B5EF4-FFF2-40B4-BE49-F238E27FC236}">
+                <a16:creationId xmlns:a16="http://schemas.microsoft.com/office/drawing/2014/main" id="{C412F10A-8CFE-4175-1DAA-0FD4948150CF}"/>
+              </a:ext>
+            </a:extLst>
+          </p:cNvPr>
+          <p:cNvSpPr txBox="1"/>
+          <p:nvPr/>
+        </p:nvSpPr>
+        <p:spPr>
+          <a:xfrm>
+            <a:off x="535021" y="6050604"/>
+            <a:ext cx="10077856" cy="276999"/>
+          </a:xfrm>
+          <a:prstGeom prst="rect">
+            <a:avLst/>
+          </a:prstGeom>
+          <a:noFill/>
+        </p:spPr>
+        <p:txBody>
+          <a:bodyPr wrap="square" rtlCol="0">
+            <a:spAutoFit/>
+          </a:bodyPr>
+          <a:lstStyle/>
+          <a:p>
+            <a:r>
+              <a:rPr lang="en-US" sz="1200" i="1" dirty="0"/>
+              <a:t>Note: Validated on 1,062 frames (</a:t>
+            </a:r>
+            <a:r>
+              <a:rPr lang="en-US" sz="1200" i="1" dirty="0" err="1"/>
+              <a:t>val</a:t>
+            </a:r>
+            <a:r>
+              <a:rPr lang="en-US" sz="1200" i="1" dirty="0"/>
+              <a:t> split), 16,081 pedestrian instances. Results saved to /content/runs/detect/</a:t>
+            </a:r>
+            <a:r>
+              <a:rPr lang="en-US" sz="1200" i="1" dirty="0" err="1"/>
+              <a:t>val</a:t>
+            </a:r>
+            <a:endParaRPr lang="en-US" sz="1200" dirty="0"/>
           </a:p>
         </p:txBody>
       </p:sp>

</xml_diff>

<commit_message>
docs: add G07 M3 presentation v2 and remove obsolete file
</commit_message>
<xml_diff>
--- a/Docs/G07_M3_Presentation_v2.pptx
+++ b/Docs/G07_M3_Presentation_v2.pptx
@@ -4360,7 +4360,7 @@
           <p:nvPr>
             <p:extLst>
               <p:ext uri="{D42A27DB-BD31-4B8C-83A1-F6EECF244321}">
-                <p14:modId xmlns:p14="http://schemas.microsoft.com/office/powerpoint/2010/main" val="514631634"/>
+                <p14:modId xmlns:p14="http://schemas.microsoft.com/office/powerpoint/2010/main" val="2524483749"/>
               </p:ext>
             </p:extLst>
           </p:nvPr>
@@ -4456,7 +4456,7 @@
                       </a:pPr>
                       <a:r>
                         <a:rPr lang="en-US" dirty="0"/>
-                        <a:t>Expected Target Range</a:t>
+                        <a:t>Initial Target Baseline</a:t>
                       </a:r>
                     </a:p>
                   </a:txBody>

</xml_diff>